<commit_message>
auto(analyze): portfolio PPT 2026-07-06T23:51:51Z
</commit_message>
<xml_diff>
--- a/reports/portfolio/2026-07-07.pptx
+++ b/reports/portfolio/2026-07-07.pptx
@@ -3193,7 +3193,7 @@
                   <a:srgbClr val="555555"/>
                 </a:solidFill>
               </a:rPr>
-              <a:t>분석 기간: 2026-06-29 00:00 ~ 2026-07-07 00:35</a:t>
+              <a:t>분석 기간: 2026-06-29 00:00 ~ 2026-07-07 08:45</a:t>
             </a:r>
           </a:p>
           <a:p>
@@ -3204,7 +3204,7 @@
                   <a:srgbClr val="555555"/>
                 </a:solidFill>
               </a:rPr>
-              <a:t>데이터: 총 2,312건 · 5분 해상도 · 전국 계통 기준</a:t>
+              <a:t>데이터: 총 2,410건 · 5분 해상도 · 전국 계통 기준</a:t>
             </a:r>
           </a:p>
           <a:p>
@@ -3215,7 +3215,7 @@
                   <a:srgbClr val="555555"/>
                 </a:solidFill>
               </a:rPr>
-              <a:t>생성일: 2026-07-07 07:42 KST</a:t>
+              <a:t>생성일: 2026-07-07 08:51 KST</a:t>
             </a:r>
           </a:p>
         </p:txBody>
@@ -4170,7 +4170,7 @@
                   <a:srgbClr val="555555"/>
                 </a:solidFill>
               </a:rPr>
-              <a:t>•  총 2,312건 · 193시간 분량 5분 해상도 수집·분석</a:t>
+              <a:t>•  총 2,410건 · 201시간 분량 5분 해상도 수집·분석</a:t>
             </a:r>
           </a:p>
           <a:p>
@@ -4185,7 +4185,7 @@
                   <a:srgbClr val="555555"/>
                 </a:solidFill>
               </a:rPr>
-              <a:t>•  다층 이상탐지 결과: EWMA:6건 · CUSUM:164건 · IForest:0건 · 잔차:4건 · LSTM-AE:스킵</a:t>
+              <a:t>•  다층 이상탐지 결과: EWMA:6건 · CUSUM:170건 · IForest:0건 · 잔차:8건 · LSTM-AE:스킵</a:t>
             </a:r>
           </a:p>
           <a:p>

</xml_diff>